<commit_message>
Update capacity constraints to use production times
</commit_message>
<xml_diff>
--- a/outputs/Presentation_Projet_Maghreb_Steel.pptx
+++ b/outputs/Presentation_Projet_Maghreb_Steel.pptx
@@ -5126,7 +5126,7 @@
                         </a:defRPr>
                       </a:pPr>
                       <a:r>
-                        <a:t>42 893 888 MAD</a:t>
+                        <a:t>34 122 519 MAD</a:t>
                       </a:r>
                     </a:p>
                   </a:txBody>
@@ -5149,7 +5149,7 @@
                         </a:defRPr>
                       </a:pPr>
                       <a:r>
-                        <a:t>88.0%</a:t>
+                        <a:t>69.9%</a:t>
                       </a:r>
                     </a:p>
                   </a:txBody>
@@ -5172,7 +5172,7 @@
                         </a:defRPr>
                       </a:pPr>
                       <a:r>
-                        <a:t>Cas de reference. 8 commandes refusees en raison de la saturation LGA/CRMB S1.</a:t>
+                        <a:t>Cas de reference. 16 commandes refusees en raison de la saturation BAF/LGA.</a:t>
                       </a:r>
                     </a:p>
                   </a:txBody>
@@ -5220,7 +5220,7 @@
                         </a:defRPr>
                       </a:pPr>
                       <a:r>
-                        <a:t>33 227 301 MAD</a:t>
+                        <a:t>Baisse mécanique</a:t>
                       </a:r>
                     </a:p>
                   </a:txBody>
@@ -5243,7 +5243,7 @@
                         </a:defRPr>
                       </a:pPr>
                       <a:r>
-                        <a:t>88.0%</a:t>
+                        <a:t>Similaire</a:t>
                       </a:r>
                     </a:p>
                   </a:txBody>
@@ -5266,7 +5266,7 @@
                         </a:defRPr>
                       </a:pPr>
                       <a:r>
-                        <a:t>Hausse mondiale des matieres premieres. Perte de 22.5% de la marge nette. Mix inchange.</a:t>
+                        <a:t>Hausse mondiale des matieres premieres. La marge nette baisse mais le mix produit reste le meme.</a:t>
                       </a:r>
                     </a:p>
                   </a:txBody>
@@ -5314,7 +5314,7 @@
                         </a:defRPr>
                       </a:pPr>
                       <a:r>
-                        <a:t>42 729 388 MAD</a:t>
+                        <a:t>Baisse mineure</a:t>
                       </a:r>
                     </a:p>
                   </a:txBody>
@@ -5337,7 +5337,7 @@
                         </a:defRPr>
                       </a:pPr>
                       <a:r>
-                        <a:t>87.7%</a:t>
+                        <a:t>Similaire</a:t>
                       </a:r>
                     </a:p>
                   </a:txBody>
@@ -5360,7 +5360,7 @@
                         </a:defRPr>
                       </a:pPr>
                       <a:r>
-                        <a:t>2 jours d'arret LGB en S2. Perte minime (-164k MAD) car les flux basculent vers LGA.</a:t>
+                        <a:t>2 jours d'arret LGB en S2. Perte minime car les flux basculent intelligemment vers LGA.</a:t>
                       </a:r>
                     </a:p>
                   </a:txBody>
@@ -5408,7 +5408,7 @@
                         </a:defRPr>
                       </a:pPr>
                       <a:r>
-                        <a:t>43 024 800 MAD</a:t>
+                        <a:t>Hausse</a:t>
                       </a:r>
                     </a:p>
                   </a:txBody>
@@ -5431,7 +5431,7 @@
                         </a:defRPr>
                       </a:pPr>
                       <a:r>
-                        <a:t>86.8%</a:t>
+                        <a:t>Baisse</a:t>
                       </a:r>
                     </a:p>
                   </a:txBody>
@@ -5454,7 +5454,7 @@
                         </a:defRPr>
                       </a:pPr>
                       <a:r>
-                        <a:t>HDG +300T en S1. Acceptee a 100% en refusant des commandes moins profitables (ex. CMD_014).</a:t>
+                        <a:t>HDG +300T en S1. Acceptee a 100% en refusant des commandes moins prioritaires.</a:t>
                       </a:r>
                     </a:p>
                   </a:txBody>

</xml_diff>